<commit_message>
Update React Component Lifecycle reference links
</commit_message>
<xml_diff>
--- a/docs/slides/DMIT2008-Week8-Day1-component-lifecycle-new.pptx
+++ b/docs/slides/DMIT2008-Week8-Day1-component-lifecycle-new.pptx
@@ -31,14 +31,15 @@
       <p:regular r:id="rId17"/>
       <p:bold r:id="rId18"/>
       <p:italic r:id="rId19"/>
+      <p:boldItalic r:id="rId20"/>
     </p:embeddedFont>
     <p:embeddedFont>
       <p:font typeface="Roboto Mono" panose="00000009000000000000" pitchFamily="49" charset="0"/>
-      <p:regular r:id="rId20"/>
+      <p:regular r:id="rId21"/>
     </p:embeddedFont>
     <p:embeddedFont>
       <p:font typeface="Roboto Slab" pitchFamily="2" charset="0"/>
-      <p:regular r:id="rId21"/>
+      <p:regular r:id="rId22"/>
     </p:embeddedFont>
   </p:embeddedFontLst>
   <p:defaultTextStyle>
@@ -270,6 +271,11 @@
       </a:defRPr>
     </a:lvl9pPr>
   </p:defaultTextStyle>
+  <p:extLst>
+    <p:ext uri="{EFAFB233-063F-42B5-8137-9DF3F51BA10A}">
+      <p15:sldGuideLst xmlns:p15="http://schemas.microsoft.com/office/powerpoint/2012/main"/>
+    </p:ext>
+  </p:extLst>
 </p:presentation>
 </file>
 
@@ -876,7 +882,7 @@
         </p:nvSpPr>
         <p:spPr>
           <a:xfrm>
-            <a:off x="381300" y="685800"/>
+            <a:off x="381000" y="685800"/>
             <a:ext cx="6096000" cy="3429000"/>
           </a:xfrm>
           <a:custGeom>
@@ -1084,7 +1090,7 @@
         </p:nvSpPr>
         <p:spPr>
           <a:xfrm>
-            <a:off x="381300" y="685800"/>
+            <a:off x="381000" y="685800"/>
             <a:ext cx="6096000" cy="3429000"/>
           </a:xfrm>
           <a:custGeom>
@@ -1147,7 +1153,91 @@
               </a:spcAft>
               <a:buNone/>
             </a:pPr>
-            <a:endParaRPr/>
+            <a:r>
+              <a:rPr lang="en-US" dirty="0"/>
+              <a:t>Practical Usage of </a:t>
+            </a:r>
+            <a:r>
+              <a:rPr lang="en-US" dirty="0" err="1"/>
+              <a:t>useEffect</a:t>
+            </a:r>
+            <a:r>
+              <a:rPr lang="en-US" dirty="0"/>
+              <a:t> Unmounting:</a:t>
+            </a:r>
+          </a:p>
+          <a:p>
+            <a:pPr marL="228600" lvl="0" indent="-228600" algn="l" rtl="0">
+              <a:spcBef>
+                <a:spcPts val="0"/>
+              </a:spcBef>
+              <a:spcAft>
+                <a:spcPts val="0"/>
+              </a:spcAft>
+              <a:buAutoNum type="arabicPeriod"/>
+            </a:pPr>
+            <a:r>
+              <a:rPr lang="en-US" dirty="0"/>
+              <a:t>Setting up connection to an external system</a:t>
+            </a:r>
+          </a:p>
+          <a:p>
+            <a:pPr marL="228600" lvl="0" indent="-228600" algn="l" rtl="0">
+              <a:spcBef>
+                <a:spcPts val="0"/>
+              </a:spcBef>
+              <a:spcAft>
+                <a:spcPts val="0"/>
+              </a:spcAft>
+              <a:buAutoNum type="arabicPeriod"/>
+            </a:pPr>
+            <a:r>
+              <a:rPr lang="en-US" dirty="0"/>
+              <a:t>Then, cleaning up the code to disconnect to the external system.</a:t>
+            </a:r>
+          </a:p>
+          <a:p>
+            <a:pPr marL="0" lvl="0" indent="0" algn="l" rtl="0">
+              <a:spcBef>
+                <a:spcPts val="0"/>
+              </a:spcBef>
+              <a:spcAft>
+                <a:spcPts val="0"/>
+              </a:spcAft>
+              <a:buNone/>
+            </a:pPr>
+            <a:endParaRPr lang="en-US" dirty="0"/>
+          </a:p>
+          <a:p>
+            <a:pPr marL="0" lvl="0" indent="0" algn="l" rtl="0">
+              <a:spcBef>
+                <a:spcPts val="0"/>
+              </a:spcBef>
+              <a:spcAft>
+                <a:spcPts val="0"/>
+              </a:spcAft>
+              <a:buNone/>
+            </a:pPr>
+            <a:r>
+              <a:rPr lang="en-US" dirty="0"/>
+              <a:t>See example below:</a:t>
+            </a:r>
+          </a:p>
+          <a:p>
+            <a:pPr marL="0" lvl="0" indent="0" algn="l" rtl="0">
+              <a:spcBef>
+                <a:spcPts val="0"/>
+              </a:spcBef>
+              <a:spcAft>
+                <a:spcPts val="0"/>
+              </a:spcAft>
+              <a:buNone/>
+            </a:pPr>
+            <a:r>
+              <a:rPr lang="en-CA" dirty="0"/>
+              <a:t>https://react.dev/reference/react/useEffect#connecting-to-an-external-system</a:t>
+            </a:r>
+            <a:endParaRPr dirty="0"/>
           </a:p>
         </p:txBody>
       </p:sp>
@@ -1188,7 +1278,7 @@
         </p:nvSpPr>
         <p:spPr>
           <a:xfrm>
-            <a:off x="381300" y="685800"/>
+            <a:off x="381000" y="685800"/>
             <a:ext cx="6096000" cy="3429000"/>
           </a:xfrm>
           <a:custGeom>
@@ -1251,7 +1341,15 @@
               </a:spcAft>
               <a:buNone/>
             </a:pPr>
-            <a:endParaRPr/>
+            <a:r>
+              <a:rPr lang="en-US"/>
+              <a:t>Reference</a:t>
+            </a:r>
+            <a:r>
+              <a:rPr lang="en-US" dirty="0"/>
+              <a:t>: https://react.dev/reference/react/Component#migrating-a-component-with-lifecycle-methods-from-a-class-to-a-function</a:t>
+            </a:r>
+            <a:endParaRPr dirty="0"/>
           </a:p>
         </p:txBody>
       </p:sp>
@@ -1812,7 +1910,7 @@
         </p:nvSpPr>
         <p:spPr>
           <a:xfrm>
-            <a:off x="381300" y="685800"/>
+            <a:off x="381000" y="685800"/>
             <a:ext cx="6096000" cy="3429000"/>
           </a:xfrm>
           <a:custGeom>
@@ -2124,7 +2222,7 @@
         </p:nvSpPr>
         <p:spPr>
           <a:xfrm>
-            <a:off x="381300" y="685800"/>
+            <a:off x="381000" y="685800"/>
             <a:ext cx="6096000" cy="3429000"/>
           </a:xfrm>
           <a:custGeom>
@@ -7811,10 +7909,10 @@
               <a:buNone/>
             </a:pPr>
             <a:r>
-              <a:rPr lang="en" sz="1100"/>
+              <a:rPr lang="en" sz="1100" dirty="0"/>
               <a:t>Mounting essentially means it’s adding the nodes contained within to the react component. In Vanilla this is like a function that is fired every time you would call “nodeOnPage.append(node)”.</a:t>
             </a:r>
-            <a:endParaRPr sz="1100"/>
+            <a:endParaRPr sz="1100" dirty="0"/>
           </a:p>
           <a:p>
             <a:pPr marL="0" lvl="0" indent="0" algn="l" rtl="0">
@@ -7827,10 +7925,10 @@
               <a:buNone/>
             </a:pPr>
             <a:r>
-              <a:rPr lang="en" sz="1100"/>
+              <a:rPr lang="en" sz="1100" dirty="0"/>
               <a:t>This is going to be a pretty common use case as this is an easy way to get data and render it on our page.</a:t>
             </a:r>
-            <a:endParaRPr sz="1100"/>
+            <a:endParaRPr sz="1100" dirty="0"/>
           </a:p>
           <a:p>
             <a:pPr marL="0" lvl="0" indent="0" algn="l" rtl="0">
@@ -7843,11 +7941,11 @@
               <a:buNone/>
             </a:pPr>
             <a:r>
-              <a:rPr lang="en" sz="1100"/>
+              <a:rPr lang="en" sz="1100" dirty="0"/>
               <a:t>Let’s take a look at the example on the right, we have the stateful variable “</a:t>
             </a:r>
             <a:r>
-              <a:rPr lang="en" sz="1050">
+              <a:rPr lang="en" sz="1050" dirty="0">
                 <a:solidFill>
                   <a:srgbClr val="ECEFF1"/>
                 </a:solidFill>
@@ -7859,11 +7957,11 @@
               <a:t>text</a:t>
             </a:r>
             <a:r>
-              <a:rPr lang="en" sz="1100"/>
+              <a:rPr lang="en" sz="1100" dirty="0"/>
               <a:t>” which we initialize with the string “</a:t>
             </a:r>
             <a:r>
-              <a:rPr lang="en" sz="1050">
+              <a:rPr lang="en" sz="1050" dirty="0">
                 <a:solidFill>
                   <a:srgbClr val="9CCC65"/>
                 </a:solidFill>
@@ -7875,10 +7973,10 @@
               <a:t>original</a:t>
             </a:r>
             <a:r>
-              <a:rPr lang="en" sz="1100"/>
+              <a:rPr lang="en" sz="1100" dirty="0"/>
               <a:t>”.</a:t>
             </a:r>
-            <a:endParaRPr sz="1100"/>
+            <a:endParaRPr sz="1100" dirty="0"/>
           </a:p>
           <a:p>
             <a:pPr marL="0" lvl="0" indent="0" algn="l" rtl="0">
@@ -7891,11 +7989,11 @@
               <a:buNone/>
             </a:pPr>
             <a:r>
-              <a:rPr lang="en" sz="1100"/>
+              <a:rPr lang="en" sz="1100" dirty="0"/>
               <a:t>This is our “</a:t>
             </a:r>
             <a:r>
-              <a:rPr lang="en" sz="1050">
+              <a:rPr lang="en" sz="1050" dirty="0">
                 <a:solidFill>
                   <a:srgbClr val="ECEFF1"/>
                 </a:solidFill>
@@ -7907,11 +8005,11 @@
               <a:t>App</a:t>
             </a:r>
             <a:r>
-              <a:rPr lang="en" sz="1100"/>
+              <a:rPr lang="en" sz="1100" dirty="0"/>
               <a:t>” component which is mounted to the page immediately. Our component checks for “</a:t>
             </a:r>
             <a:r>
-              <a:rPr lang="en" sz="1050">
+              <a:rPr lang="en" sz="1050" dirty="0">
                 <a:solidFill>
                   <a:srgbClr val="ECEFF1"/>
                 </a:solidFill>
@@ -7923,11 +8021,11 @@
               <a:t>useEffect</a:t>
             </a:r>
             <a:r>
-              <a:rPr lang="en" sz="1100"/>
+              <a:rPr lang="en" sz="1100" dirty="0"/>
               <a:t>” on mount, and sees there is one because of the empty dependency array “</a:t>
             </a:r>
             <a:r>
-              <a:rPr lang="en" sz="1050">
+              <a:rPr lang="en" sz="1050" dirty="0">
                 <a:solidFill>
                   <a:srgbClr val="ECEFF1"/>
                 </a:solidFill>
@@ -7939,11 +8037,11 @@
               <a:t>[]</a:t>
             </a:r>
             <a:r>
-              <a:rPr lang="en" sz="1100"/>
+              <a:rPr lang="en" sz="1100" dirty="0"/>
               <a:t>” . There is an effect so the first argument (the function) of the first “</a:t>
             </a:r>
             <a:r>
-              <a:rPr lang="en" sz="1050">
+              <a:rPr lang="en" sz="1050" dirty="0">
                 <a:solidFill>
                   <a:srgbClr val="ECEFF1"/>
                 </a:solidFill>
@@ -7955,11 +8053,11 @@
               <a:t>useEffect</a:t>
             </a:r>
             <a:r>
-              <a:rPr lang="en" sz="1100"/>
+              <a:rPr lang="en" sz="1100" dirty="0"/>
               <a:t>” is fired. This changes the “</a:t>
             </a:r>
             <a:r>
-              <a:rPr lang="en" sz="1050">
+              <a:rPr lang="en" sz="1050" dirty="0">
                 <a:solidFill>
                   <a:srgbClr val="ECEFF1"/>
                 </a:solidFill>
@@ -7971,11 +8069,11 @@
               <a:t>text</a:t>
             </a:r>
             <a:r>
-              <a:rPr lang="en" sz="1100"/>
+              <a:rPr lang="en" sz="1100" dirty="0"/>
               <a:t>” variable to “</a:t>
             </a:r>
             <a:r>
-              <a:rPr lang="en" sz="1150">
+              <a:rPr lang="en" sz="1150" dirty="0">
                 <a:solidFill>
                   <a:srgbClr val="9CCC65"/>
                 </a:solidFill>
@@ -7987,10 +8085,10 @@
               <a:t>fired on mount</a:t>
             </a:r>
             <a:r>
-              <a:rPr lang="en" sz="1100"/>
+              <a:rPr lang="en" sz="1100" dirty="0"/>
               <a:t>”.</a:t>
             </a:r>
-            <a:endParaRPr sz="1100"/>
+            <a:endParaRPr sz="1100" dirty="0"/>
           </a:p>
           <a:p>
             <a:pPr marL="0" lvl="0" indent="0" algn="l" rtl="0">
@@ -8002,7 +8100,7 @@
               </a:spcAft>
               <a:buNone/>
             </a:pPr>
-            <a:endParaRPr sz="1100"/>
+            <a:endParaRPr sz="1100" dirty="0"/>
           </a:p>
         </p:txBody>
       </p:sp>
@@ -8041,7 +8139,7 @@
               <a:buNone/>
             </a:pPr>
             <a:r>
-              <a:rPr lang="en" u="sng">
+              <a:rPr lang="en" u="sng" dirty="0">
                 <a:solidFill>
                   <a:schemeClr val="hlink"/>
                 </a:solidFill>
@@ -8050,10 +8148,10 @@
               <a:t>Here’s an example of it live</a:t>
             </a:r>
             <a:r>
-              <a:rPr lang="en"/>
+              <a:rPr lang="en" dirty="0"/>
               <a:t> (click “Run with js”)</a:t>
             </a:r>
-            <a:endParaRPr/>
+            <a:endParaRPr dirty="0"/>
           </a:p>
         </p:txBody>
       </p:sp>
@@ -9222,7 +9320,7 @@
               <a:buNone/>
             </a:pPr>
             <a:r>
-              <a:rPr lang="en" u="sng">
+              <a:rPr lang="en" u="sng" dirty="0">
                 <a:solidFill>
                   <a:schemeClr val="hlink"/>
                 </a:solidFill>
@@ -9231,10 +9329,10 @@
               <a:t>Here’s an example of it live</a:t>
             </a:r>
             <a:r>
-              <a:rPr lang="en"/>
+              <a:rPr lang="en" dirty="0"/>
               <a:t> (click “Run with js”)</a:t>
             </a:r>
-            <a:endParaRPr/>
+            <a:endParaRPr dirty="0"/>
           </a:p>
         </p:txBody>
       </p:sp>
@@ -12257,7 +12355,7 @@
               <a:buNone/>
             </a:pPr>
             <a:r>
-              <a:rPr lang="en" b="1">
+              <a:rPr lang="en" b="1" dirty="0">
                 <a:solidFill>
                   <a:schemeClr val="dk1"/>
                 </a:solidFill>
@@ -12268,7 +12366,7 @@
               </a:rPr>
               <a:t>1. Mounting</a:t>
             </a:r>
-            <a:endParaRPr b="1">
+            <a:endParaRPr b="1" dirty="0">
               <a:solidFill>
                 <a:schemeClr val="dk1"/>
               </a:solidFill>
@@ -12289,7 +12387,7 @@
               <a:buNone/>
             </a:pPr>
             <a:r>
-              <a:rPr lang="en" sz="1000">
+              <a:rPr lang="en" sz="1000" dirty="0">
                 <a:solidFill>
                   <a:schemeClr val="dk1"/>
                 </a:solidFill>
@@ -12301,7 +12399,7 @@
               <a:t>Here you can run a function when a component is created, and runs before your JSX is rendered.</a:t>
             </a:r>
             <a:br>
-              <a:rPr lang="en" sz="1000">
+              <a:rPr lang="en" sz="1000" dirty="0">
                 <a:solidFill>
                   <a:schemeClr val="dk1"/>
                 </a:solidFill>
@@ -12312,7 +12410,7 @@
               </a:rPr>
             </a:br>
             <a:r>
-              <a:rPr lang="en" sz="1000" i="1">
+              <a:rPr lang="en" sz="1000" i="1" dirty="0">
                 <a:solidFill>
                   <a:schemeClr val="dk1"/>
                 </a:solidFill>
@@ -12323,7 +12421,7 @@
               </a:rPr>
               <a:t>Note: You need an empty dependency array for this.</a:t>
             </a:r>
-            <a:endParaRPr sz="1000" i="1">
+            <a:endParaRPr sz="1000" i="1" dirty="0">
               <a:solidFill>
                 <a:schemeClr val="dk1"/>
               </a:solidFill>
@@ -12607,7 +12705,7 @@
               <a:buNone/>
             </a:pPr>
             <a:r>
-              <a:rPr lang="en" sz="1000">
+              <a:rPr lang="en" sz="1000" dirty="0">
                 <a:solidFill>
                   <a:srgbClr val="ECEFF1"/>
                 </a:solidFill>
@@ -12618,7 +12716,7 @@
               </a:rPr>
               <a:t>componentDidMount() {}</a:t>
             </a:r>
-            <a:endParaRPr sz="1000">
+            <a:endParaRPr sz="1000" dirty="0">
               <a:solidFill>
                 <a:srgbClr val="ECEFF1"/>
               </a:solidFill>
@@ -13420,10 +13518,10 @@
               <a:buNone/>
             </a:pPr>
             <a:r>
-              <a:rPr lang="en" sz="1400"/>
+              <a:rPr lang="en" sz="1400" dirty="0"/>
               <a:t>So far in our React journey we know that everything is contained within components.</a:t>
             </a:r>
-            <a:endParaRPr sz="1400"/>
+            <a:endParaRPr sz="1400" dirty="0"/>
           </a:p>
           <a:p>
             <a:pPr marL="0" lvl="0" indent="0" algn="l" rtl="0">
@@ -13436,10 +13534,10 @@
               <a:buNone/>
             </a:pPr>
             <a:r>
-              <a:rPr lang="en" sz="1400"/>
+              <a:rPr lang="en" sz="1400" dirty="0"/>
               <a:t>Within React components events essentially fire when some type of user interaction happens on the page. A user clicks something, a key is typed, the mouse is moved, etc.</a:t>
             </a:r>
-            <a:endParaRPr sz="1400"/>
+            <a:endParaRPr sz="1400" dirty="0"/>
           </a:p>
           <a:p>
             <a:pPr marL="0" lvl="0" indent="0" algn="l" rtl="0">
@@ -13452,10 +13550,10 @@
               <a:buNone/>
             </a:pPr>
             <a:r>
-              <a:rPr lang="en" sz="1400"/>
+              <a:rPr lang="en" sz="1400" dirty="0"/>
               <a:t>Within React components state essentially keeps our data that is being rendered in our JSX (the layout) inline with what our code and functions are doing.</a:t>
             </a:r>
-            <a:endParaRPr sz="1400"/>
+            <a:endParaRPr sz="1400" dirty="0"/>
           </a:p>
           <a:p>
             <a:pPr marL="0" lvl="0" indent="0" algn="l" rtl="0">
@@ -13468,10 +13566,10 @@
               <a:buNone/>
             </a:pPr>
             <a:r>
-              <a:rPr lang="en" sz="1400"/>
+              <a:rPr lang="en" sz="1400" dirty="0"/>
               <a:t>You’re probably thinking to yourself, that’s great but what if I want to run something immediately when a component is called? Say you have a page of reviews and you want them to load instantaneously, rather than have to click a button. </a:t>
             </a:r>
-            <a:endParaRPr sz="1400"/>
+            <a:endParaRPr sz="1400" dirty="0"/>
           </a:p>
           <a:p>
             <a:pPr marL="0" lvl="0" indent="0" algn="l" rtl="0">
@@ -13484,10 +13582,10 @@
               <a:buNone/>
             </a:pPr>
             <a:r>
-              <a:rPr lang="en" sz="1400"/>
+              <a:rPr lang="en" sz="1400" dirty="0"/>
               <a:t>And as well what if you want to debug or fire an event on every change of a variables state?</a:t>
             </a:r>
-            <a:endParaRPr sz="1400"/>
+            <a:endParaRPr sz="1400" dirty="0"/>
           </a:p>
           <a:p>
             <a:pPr marL="0" lvl="0" indent="0" algn="l" rtl="0">
@@ -13500,10 +13598,10 @@
               <a:buNone/>
             </a:pPr>
             <a:r>
-              <a:rPr lang="en" sz="1400"/>
+              <a:rPr lang="en" sz="1400" dirty="0"/>
               <a:t>This is where the lifecycle of a component comes in.</a:t>
             </a:r>
-            <a:endParaRPr sz="1400"/>
+            <a:endParaRPr sz="1400" dirty="0"/>
           </a:p>
         </p:txBody>
       </p:sp>
@@ -13609,10 +13707,10 @@
               <a:buNone/>
             </a:pPr>
             <a:r>
-              <a:rPr lang="en" sz="1600"/>
+              <a:rPr lang="en" sz="1600" dirty="0"/>
               <a:t>Sometimes you want a component to do something right when it is added to the page, say for example you want to load data on the client! You can do that, using the lifecycle.</a:t>
             </a:r>
-            <a:endParaRPr sz="1600"/>
+            <a:endParaRPr sz="1600" dirty="0"/>
           </a:p>
           <a:p>
             <a:pPr marL="0" lvl="0" indent="0" algn="l" rtl="0">
@@ -13625,10 +13723,9 @@
               <a:buNone/>
             </a:pPr>
             <a:r>
-              <a:rPr lang="en" sz="1600"/>
-              <a:t>Say for example in the case of loading a quote (just like the example!) on the client rather than having the user click a button (we’ll do this in an example)</a:t>
-            </a:r>
-            <a:endParaRPr sz="1600"/>
+              <a:rPr lang="en" sz="1600" dirty="0"/>
+              <a:t>Say for example in the case of loading a reviews (just like the example!) on the client rather than having the user click a button.</a:t>
+            </a:r>
           </a:p>
           <a:p>
             <a:pPr marL="0" lvl="0" indent="0" algn="l" rtl="0">
@@ -13641,10 +13738,10 @@
               <a:buNone/>
             </a:pPr>
             <a:r>
-              <a:rPr lang="en" sz="1600"/>
+              <a:rPr lang="en" sz="1600" dirty="0"/>
               <a:t>Another use case is you want to log changes of a stateful variable, or you’d like to do something when it changes (this isn’t always the case but you might have some functionality that this is required). </a:t>
             </a:r>
-            <a:endParaRPr sz="1600"/>
+            <a:endParaRPr sz="1600" dirty="0"/>
           </a:p>
           <a:p>
             <a:pPr marL="0" lvl="0" indent="0" algn="l" rtl="0">
@@ -13657,10 +13754,10 @@
               <a:buNone/>
             </a:pPr>
             <a:r>
-              <a:rPr lang="en" sz="1600"/>
+              <a:rPr lang="en" sz="1600" dirty="0"/>
               <a:t>This is really important to know as a frontend developer as all component based libraries (most of them) have a very similar lifecycle, so this concept is very relatable to Vue.js Solid.js, Angular.js etc.</a:t>
             </a:r>
-            <a:endParaRPr sz="1600"/>
+            <a:endParaRPr sz="1600" dirty="0"/>
           </a:p>
         </p:txBody>
       </p:sp>
@@ -14089,10 +14186,10 @@
               <a:buNone/>
             </a:pPr>
             <a:r>
-              <a:rPr lang="en" sz="1200"/>
+              <a:rPr lang="en" sz="1200" dirty="0"/>
               <a:t>We’re going to look at different ways to use the dependency array to get the first argument (the callback) to be called at the right time in the lifecycle.</a:t>
             </a:r>
-            <a:endParaRPr sz="1200"/>
+            <a:endParaRPr sz="1200" dirty="0"/>
           </a:p>
           <a:p>
             <a:pPr marL="0" lvl="0" indent="0" algn="l" rtl="0">
@@ -14105,10 +14202,10 @@
               <a:buNone/>
             </a:pPr>
             <a:r>
-              <a:rPr lang="en" sz="1200"/>
+              <a:rPr lang="en" sz="1200" dirty="0"/>
               <a:t>Note: useEffect like all hooks need to be at the root of the component.</a:t>
             </a:r>
-            <a:endParaRPr sz="1200"/>
+            <a:endParaRPr sz="1200" dirty="0"/>
           </a:p>
         </p:txBody>
       </p:sp>
@@ -14728,7 +14825,7 @@
               <a:buNone/>
             </a:pPr>
             <a:r>
-              <a:rPr lang="en" b="1">
+              <a:rPr lang="en" b="1" dirty="0">
                 <a:solidFill>
                   <a:schemeClr val="dk1"/>
                 </a:solidFill>
@@ -14739,7 +14836,7 @@
               </a:rPr>
               <a:t>2. Updating</a:t>
             </a:r>
-            <a:endParaRPr b="1">
+            <a:endParaRPr b="1" dirty="0">
               <a:solidFill>
                 <a:schemeClr val="dk1"/>
               </a:solidFill>
@@ -14760,7 +14857,7 @@
               <a:buNone/>
             </a:pPr>
             <a:r>
-              <a:rPr lang="en" sz="1000">
+              <a:rPr lang="en" sz="1000" dirty="0">
                 <a:solidFill>
                   <a:schemeClr val="dk1"/>
                 </a:solidFill>
@@ -14772,7 +14869,7 @@
               <a:t>You can run functions when a specific variable is updated, or when any variable is updated (or is mounted).</a:t>
             </a:r>
             <a:br>
-              <a:rPr lang="en" sz="1000">
+              <a:rPr lang="en" sz="1000" dirty="0">
                 <a:solidFill>
                   <a:schemeClr val="dk1"/>
                 </a:solidFill>
@@ -14783,7 +14880,7 @@
               </a:rPr>
             </a:br>
             <a:r>
-              <a:rPr lang="en" sz="1000" i="1">
+              <a:rPr lang="en" sz="1000" i="1" dirty="0">
                 <a:solidFill>
                   <a:schemeClr val="dk1"/>
                 </a:solidFill>
@@ -14795,7 +14892,7 @@
               <a:t>Note: you either need to specify the stateful variable in the dependency array OR don’t specify it and the effect will run everytime something is updated (this is not ideal).</a:t>
             </a:r>
             <a:br>
-              <a:rPr lang="en" sz="1000">
+              <a:rPr lang="en" sz="1000" dirty="0">
                 <a:solidFill>
                   <a:schemeClr val="dk1"/>
                 </a:solidFill>
@@ -14805,7 +14902,7 @@
                 <a:sym typeface="Roboto"/>
               </a:rPr>
             </a:br>
-            <a:endParaRPr>
+            <a:endParaRPr dirty="0">
               <a:solidFill>
                 <a:schemeClr val="dk1"/>
               </a:solidFill>
@@ -15196,7 +15293,7 @@
         <p:spPr>
           <a:xfrm>
             <a:off x="3060250" y="3111550"/>
-            <a:ext cx="3151200" cy="1569900"/>
+            <a:ext cx="3151200" cy="1641958"/>
           </a:xfrm>
           <a:prstGeom prst="rect">
             <a:avLst/>
@@ -15222,7 +15319,7 @@
               <a:buNone/>
             </a:pPr>
             <a:r>
-              <a:rPr lang="en" sz="1000">
+              <a:rPr lang="en" sz="1000" dirty="0">
                 <a:solidFill>
                   <a:srgbClr val="F06292"/>
                 </a:solidFill>
@@ -15233,7 +15330,7 @@
               </a:rPr>
               <a:t>// 2. Run on Update</a:t>
             </a:r>
-            <a:endParaRPr sz="1000">
+            <a:endParaRPr sz="1000" dirty="0">
               <a:solidFill>
                 <a:srgbClr val="ECEFF1"/>
               </a:solidFill>
@@ -15254,7 +15351,7 @@
               <a:buNone/>
             </a:pPr>
             <a:r>
-              <a:rPr lang="en" sz="1000">
+              <a:rPr lang="en" sz="1000" dirty="0">
                 <a:solidFill>
                   <a:srgbClr val="F06292"/>
                 </a:solidFill>
@@ -15265,7 +15362,7 @@
               </a:rPr>
               <a:t>// example stateful variable.</a:t>
             </a:r>
-            <a:endParaRPr sz="1000">
+            <a:endParaRPr sz="1000" dirty="0">
               <a:solidFill>
                 <a:srgbClr val="ECEFF1"/>
               </a:solidFill>
@@ -15286,7 +15383,7 @@
               <a:buNone/>
             </a:pPr>
             <a:r>
-              <a:rPr lang="en" sz="1000">
+              <a:rPr lang="en" sz="1000" dirty="0">
                 <a:solidFill>
                   <a:srgbClr val="4DD0E1"/>
                 </a:solidFill>
@@ -15298,7 +15395,7 @@
               <a:t>const</a:t>
             </a:r>
             <a:r>
-              <a:rPr lang="en" sz="1000">
+              <a:rPr lang="en" sz="1000" dirty="0">
                 <a:solidFill>
                   <a:srgbClr val="ECEFF1"/>
                 </a:solidFill>
@@ -15309,7 +15406,7 @@
               </a:rPr>
               <a:t> [thing, setThing] = useState()</a:t>
             </a:r>
-            <a:endParaRPr sz="1000">
+            <a:endParaRPr sz="1000" dirty="0">
               <a:solidFill>
                 <a:srgbClr val="ECEFF1"/>
               </a:solidFill>
@@ -15329,7 +15426,7 @@
               </a:spcAft>
               <a:buNone/>
             </a:pPr>
-            <a:endParaRPr sz="1000">
+            <a:endParaRPr sz="1000" dirty="0">
               <a:solidFill>
                 <a:srgbClr val="ECEFF1"/>
               </a:solidFill>
@@ -15350,7 +15447,7 @@
               <a:buNone/>
             </a:pPr>
             <a:r>
-              <a:rPr lang="en" sz="1000">
+              <a:rPr lang="en" sz="1000" dirty="0">
                 <a:solidFill>
                   <a:srgbClr val="ECEFF1"/>
                 </a:solidFill>
@@ -15361,7 +15458,7 @@
               </a:rPr>
               <a:t>useEffect(()=&gt; {</a:t>
             </a:r>
-            <a:endParaRPr sz="1000">
+            <a:endParaRPr sz="1000" dirty="0">
               <a:solidFill>
                 <a:srgbClr val="ECEFF1"/>
               </a:solidFill>
@@ -15382,7 +15479,7 @@
               <a:buNone/>
             </a:pPr>
             <a:r>
-              <a:rPr lang="en" sz="1000">
+              <a:rPr lang="en" sz="1000" dirty="0">
                 <a:solidFill>
                   <a:srgbClr val="ECEFF1"/>
                 </a:solidFill>
@@ -15394,7 +15491,7 @@
               <a:t>  </a:t>
             </a:r>
             <a:r>
-              <a:rPr lang="en" sz="1000">
+              <a:rPr lang="en" sz="1000" dirty="0">
                 <a:solidFill>
                   <a:srgbClr val="F06292"/>
                 </a:solidFill>
@@ -15403,9 +15500,9 @@
                 <a:cs typeface="Roboto Mono"/>
                 <a:sym typeface="Roboto Mono"/>
               </a:rPr>
-              <a:t>// this will called whenever</a:t>
-            </a:r>
-            <a:endParaRPr sz="1000">
+              <a:t>// this will be called whenever</a:t>
+            </a:r>
+            <a:endParaRPr sz="1000" dirty="0">
               <a:solidFill>
                 <a:srgbClr val="ECEFF1"/>
               </a:solidFill>
@@ -15426,7 +15523,7 @@
               <a:buNone/>
             </a:pPr>
             <a:r>
-              <a:rPr lang="en" sz="1000">
+              <a:rPr lang="en" sz="1000" dirty="0">
                 <a:solidFill>
                   <a:srgbClr val="ECEFF1"/>
                 </a:solidFill>
@@ -15438,7 +15535,7 @@
               <a:t>  </a:t>
             </a:r>
             <a:r>
-              <a:rPr lang="en" sz="1000">
+              <a:rPr lang="en" sz="1000" dirty="0">
                 <a:solidFill>
                   <a:srgbClr val="F06292"/>
                 </a:solidFill>
@@ -15449,7 +15546,7 @@
               </a:rPr>
               <a:t>// we call the function "setThing"</a:t>
             </a:r>
-            <a:endParaRPr sz="1000">
+            <a:endParaRPr sz="1000" dirty="0">
               <a:solidFill>
                 <a:srgbClr val="ECEFF1"/>
               </a:solidFill>
@@ -15470,7 +15567,7 @@
               <a:buNone/>
             </a:pPr>
             <a:r>
-              <a:rPr lang="en" sz="1000">
+              <a:rPr lang="en" sz="1000" dirty="0">
                 <a:solidFill>
                   <a:srgbClr val="ECEFF1"/>
                 </a:solidFill>
@@ -15482,7 +15579,7 @@
               <a:t>  </a:t>
             </a:r>
             <a:r>
-              <a:rPr lang="en" sz="1000">
+              <a:rPr lang="en" sz="1000" dirty="0">
                 <a:solidFill>
                   <a:srgbClr val="F06292"/>
                 </a:solidFill>
@@ -15493,7 +15590,7 @@
               </a:rPr>
               <a:t>// to attempt to update the "thing"</a:t>
             </a:r>
-            <a:endParaRPr sz="1000">
+            <a:endParaRPr sz="1000" dirty="0">
               <a:solidFill>
                 <a:srgbClr val="ECEFF1"/>
               </a:solidFill>
@@ -15517,7 +15614,7 @@
               <a:buNone/>
             </a:pPr>
             <a:r>
-              <a:rPr lang="en" sz="1000">
+              <a:rPr lang="en" sz="1000" dirty="0">
                 <a:solidFill>
                   <a:srgbClr val="ECEFF1"/>
                 </a:solidFill>
@@ -15528,7 +15625,7 @@
               </a:rPr>
               <a:t>}, [thing])</a:t>
             </a:r>
-            <a:endParaRPr sz="1000">
+            <a:endParaRPr sz="1000" dirty="0">
               <a:solidFill>
                 <a:srgbClr val="ECEFF1"/>
               </a:solidFill>

</xml_diff>